<commit_message>
My STAR(T) Story deck: add required-skills setup slide
Co-Authored-By: Claude Opus 5.5 <noreply@anthropic.com>
Claude-Session: https://claude.ai/code/session_01ScysB3hpFWQZ6JoQjpf1xs
</commit_message>
<xml_diff>
--- a/downloads/slides/FYE100-My-STARt-Story-Slides.pptx
+++ b/downloads/slides/FYE100-My-STARt-Story-Slides.pptx
@@ -12,9 +12,10 @@
     <p:sldId id="260" r:id="rId6"/>
     <p:sldId id="261" r:id="rId7"/>
     <p:sldId id="262" r:id="rId8"/>
+    <p:sldId id="263" r:id="rId9"/>
   </p:sldIdLst>
   <p:notesMasterIdLst>
-    <p:notesMasterId r:id="rId9"/>
+    <p:notesMasterId r:id="rId10"/>
   </p:notesMasterIdLst>
   <p:sldSz cx="12192000" cy="6858000"/>
   <p:notesSz cx="6858000" cy="12192000"/>
@@ -598,9 +599,10 @@
           <a:p>
             <a:r>
               <a:rPr lang="en-US" dirty="0"/>
-              <a:t>SETUP: Choose your skill.
-Three of your four stories are assigned: Adaptability &amp; Leadership, Professionalism, and Knowledge Application. The fourth is your choice from the other seven skills shown here.
-Pick the skill that connects most honestly to a real experience. Then say in one sentence why you chose it.</a:t>
+              <a:t>SETUP: Your three required skills.
+Three of your four stories are assigned: Adaptability &amp; Leadership, Professionalism, and Knowledge Application. Each one gets its own story.
+Name the skill this story is about. Then pick one real moment that shows it, one you can tell in 2 to 4 minutes.
+Telling one of these stories? Hide the next slide (Choose your skill). Telling your choice story? Hide this one.</a:t>
             </a:r>
             <a:endParaRPr lang="en-US" dirty="0"/>
           </a:p>
@@ -688,10 +690,10 @@
           <a:p>
             <a:r>
               <a:rPr lang="en-US" dirty="0"/>
-              <a:t>SITUATION: Set the scene.
-What was going on, and where were you? Work, school, community, or family?
-Give just enough context for someone who wasn't there to follow along. Two or three sentences is usually enough.
-Watch out: the Situation is the setup, not the story. Keep it brief and get to the Task.</a:t>
+              <a:t>SETUP: Choose your skill.
+Your fourth story is your choice, from the seven skills shown here.
+Pick the skill that connects most honestly to a real experience. Then say in one sentence why you chose it.
+Telling your choice story? Hide the previous slide (Three required skills).</a:t>
             </a:r>
             <a:endParaRPr lang="en-US" dirty="0"/>
           </a:p>
@@ -779,9 +781,10 @@
           <a:p>
             <a:r>
               <a:rPr lang="en-US" dirty="0"/>
-              <a:t>TASK: Define your role.
-What were you trying to accomplish or solve? What was specifically yours to handle? Not the group's general goal, but your particular role or challenge.
-Watch out: "We needed to figure it out" is a group goal. Your Task is what you were responsible for.</a:t>
+              <a:t>SITUATION: Set the scene.
+What was going on, and where were you? Work, school, community, or family?
+Give just enough context for someone who wasn't there to follow along. Two or three sentences is usually enough.
+Watch out: the Situation is the setup, not the story. Keep it brief and get to the Task.</a:t>
             </a:r>
             <a:endParaRPr lang="en-US" dirty="0"/>
           </a:p>
@@ -869,10 +872,9 @@
           <a:p>
             <a:r>
               <a:rPr lang="en-US" dirty="0"/>
-              <a:t>ACTION: Show what you did. This is the most important step.
-Use "I": I decided, I communicated, I applied, I reached out. Describe the specific things you did and the choices you made.
-This is where your skill lives. Show it; don't just claim it.
-Watch out: "We worked through it together" hides your contribution. Even in a group effort, describe what you did.</a:t>
+              <a:t>TASK: Define your role.
+What were you trying to accomplish or solve? What was specifically yours to handle? Not the group's general goal, but your particular role or challenge.
+Watch out: "We needed to figure it out" is a group goal. Your Task is what you were responsible for.</a:t>
             </a:r>
             <a:endParaRPr lang="en-US" dirty="0"/>
           </a:p>
@@ -960,10 +962,10 @@
           <a:p>
             <a:r>
               <a:rPr lang="en-US" dirty="0"/>
-              <a:t>RESULT: Name the outcome.
-What changed, improved, or resolved because of what you did?
-Results don't have to be perfect. An honest, imperfect result is more believable than a vague positive one. Name what happened.
-Watch out: "It went well" is not a result.</a:t>
+              <a:t>ACTION: Show what you did. This is the most important step.
+Use "I": I decided, I communicated, I applied, I reached out. Describe the specific things you did and the choices you made.
+This is where your skill lives. Show it; don't just claim it.
+Watch out: "We worked through it together" hides your contribution. Even in a group effort, describe what you did.</a:t>
             </a:r>
             <a:endParaRPr lang="en-US" dirty="0"/>
           </a:p>
@@ -1051,10 +1053,10 @@
           <a:p>
             <a:r>
               <a:rPr lang="en-US" dirty="0"/>
-              <a:t>TRANSFER: Connect it forward. This step is unique to this course.
-What does this experience mean for your next semester, your career, or your life? This is where your story becomes more than a memory. It becomes evidence of who you're becoming.
-Be specific about where this skill will show up next: a particular program, a type of work, a relationship, or a responsibility.
-Watch out: "This will help me in the future" is not a Transfer. Name the specific context where this skill will matter.</a:t>
+              <a:t>RESULT: Name the outcome.
+What changed, improved, or resolved because of what you did?
+Results don't have to be perfect. An honest, imperfect result is more believable than a vague positive one. Name what happened.
+Watch out: "It went well" is not a result.</a:t>
             </a:r>
             <a:endParaRPr lang="en-US" dirty="0"/>
           </a:p>
@@ -1078,6 +1080,97 @@
             <a:fld id="{F7021451-1387-4CA6-816F-3879F97B5CBC}" type="slidenum">
               <a:rPr lang="en-US"/>
               <a:t>7</a:t>
+            </a:fld>
+            <a:endParaRPr lang="en-US"/>
+          </a:p>
+        </p:txBody>
+      </p:sp>
+    </p:spTree>
+    <p:extLst>
+      <p:ext uri="{BB962C8B-B14F-4D97-AF65-F5344CB8AC3E}">
+        <p14:creationId xmlns:p14="http://schemas.microsoft.com/office/powerpoint/2010/main" val="1024086991"/>
+      </p:ext>
+    </p:extLst>
+  </p:cSld>
+  <p:clrMapOvr>
+    <a:masterClrMapping/>
+  </p:clrMapOvr>
+</p:notes>
+</file>
+
+<file path=ppt/notesSlides/notesSlide8.xml><?xml version="1.0" encoding="utf-8"?>
+<p:notes xmlns:a="http://schemas.openxmlformats.org/drawingml/2006/main" xmlns:r="http://schemas.openxmlformats.org/officeDocument/2006/relationships" xmlns:p="http://schemas.openxmlformats.org/presentationml/2006/main">
+  <p:cSld>
+    <p:spTree>
+      <p:nvGrpSpPr>
+        <p:cNvPr id="1" name=""/>
+        <p:cNvGrpSpPr/>
+        <p:nvPr/>
+      </p:nvGrpSpPr>
+      <p:grpSpPr>
+        <a:xfrm>
+          <a:off x="0" y="0"/>
+          <a:ext cx="0" cy="0"/>
+          <a:chOff x="0" y="0"/>
+          <a:chExt cx="0" cy="0"/>
+        </a:xfrm>
+      </p:grpSpPr>
+      <p:sp>
+        <p:nvSpPr>
+          <p:cNvPr id="2" name="Slide Image Placeholder 1"/>
+          <p:cNvSpPr>
+            <a:spLocks noGrp="1" noRot="1" noChangeAspect="1"/>
+          </p:cNvSpPr>
+          <p:nvPr>
+            <p:ph type="sldImg"/>
+          </p:nvPr>
+        </p:nvSpPr>
+        <p:spPr/>
+      </p:sp>
+      <p:sp>
+        <p:nvSpPr>
+          <p:cNvPr id="3" name="Notes Placeholder 2"/>
+          <p:cNvSpPr>
+            <a:spLocks noGrp="1"/>
+          </p:cNvSpPr>
+          <p:nvPr>
+            <p:ph type="body" idx="1"/>
+          </p:nvPr>
+        </p:nvSpPr>
+        <p:spPr/>
+        <p:txBody>
+          <a:bodyPr/>
+          <a:lstStyle/>
+          <a:p>
+            <a:r>
+              <a:rPr lang="en-US" dirty="0"/>
+              <a:t>TRANSFER: Connect it forward. This step is unique to this course.
+What does this experience mean for your next semester, your career, or your life? This is where your story becomes more than a memory. It becomes evidence of who you're becoming.
+Be specific about where this skill will show up next: a particular program, a type of work, a relationship, or a responsibility.
+Watch out: "This will help me in the future" is not a Transfer. Name the specific context where this skill will matter.</a:t>
+            </a:r>
+            <a:endParaRPr lang="en-US" dirty="0"/>
+          </a:p>
+        </p:txBody>
+      </p:sp>
+      <p:sp>
+        <p:nvSpPr>
+          <p:cNvPr id="4" name="Slide Number Placeholder 3"/>
+          <p:cNvSpPr>
+            <a:spLocks noGrp="1"/>
+          </p:cNvSpPr>
+          <p:nvPr>
+            <p:ph type="sldNum" sz="quarter" idx="10"/>
+          </p:nvPr>
+        </p:nvSpPr>
+        <p:spPr/>
+        <p:txBody>
+          <a:bodyPr/>
+          <a:lstStyle/>
+          <a:p>
+            <a:fld id="{F7021451-1387-4CA6-816F-3879F97B5CBC}" type="slidenum">
+              <a:rPr lang="en-US"/>
+              <a:t>8</a:t>
             </a:fld>
             <a:endParaRPr lang="en-US"/>
           </a:p>
@@ -2053,7 +2146,7 @@
                   <a:srgbClr val="FFFFFF"/>
                 </a:solidFill>
               </a:rPr>
-              <a:t>Choose your skill</a:t>
+              <a:t>Three required skills</a:t>
             </a:r>
             <a:endParaRPr lang="en-US" sz="5400" dirty="0"/>
           </a:p>
@@ -2067,7 +2160,7 @@
         </p:nvSpPr>
         <p:spPr>
           <a:xfrm>
-            <a:off x="1371600" y="685800"/>
+            <a:off x="1371600" y="411480"/>
             <a:ext cx="9448495" cy="457200"/>
           </a:xfrm>
           <a:prstGeom prst="rect">
@@ -2092,7 +2185,7 @@
                 <a:ea typeface="Calibri" pitchFamily="34" charset="-122"/>
                 <a:cs typeface="Calibri" pitchFamily="34" charset="-120"/>
               </a:rPr>
-              <a:t>SETUP · STEP 0</a:t>
+              <a:t>SETUP · REQUIRED STORIES</a:t>
             </a:r>
             <a:endParaRPr lang="en-US" sz="2200" dirty="0"/>
           </a:p>
@@ -2100,7 +2193,7 @@
       </p:sp>
       <p:pic>
         <p:nvPicPr>
-          <p:cNvPr id="4" name="Skill 1 coin" descr="Essential Skill 1: Communication">    </p:cNvPr>
+          <p:cNvPr id="4" name="Skill 5 coin" descr="Essential Skill 5: Adaptability &amp; Leadership">    </p:cNvPr>
           <p:cNvPicPr>
             <a:picLocks noChangeAspect="1"/>
           </p:cNvPicPr>
@@ -2114,17 +2207,56 @@
         </p:blipFill>
         <p:spPr>
           <a:xfrm>
-            <a:off x="1912468" y="1371600"/>
-            <a:ext cx="960120" cy="960120"/>
+            <a:off x="2118208" y="868680"/>
+            <a:ext cx="1188720" cy="1188720"/>
           </a:xfrm>
           <a:prstGeom prst="rect">
             <a:avLst/>
           </a:prstGeom>
         </p:spPr>
       </p:pic>
+      <p:sp>
+        <p:nvSpPr>
+          <p:cNvPr id="5" name="Text 2"/>
+          <p:cNvSpPr txBox="1"/>
+          <p:nvPr/>
+        </p:nvSpPr>
+        <p:spPr>
+          <a:xfrm>
+            <a:off x="1020928" y="2103120"/>
+            <a:ext cx="3383280" cy="457200"/>
+          </a:xfrm>
+          <a:prstGeom prst="rect">
+            <a:avLst/>
+          </a:prstGeom>
+          <a:noFill/>
+          <a:ln/>
+        </p:spPr>
+        <p:txBody>
+          <a:bodyPr wrap="square" lIns="0" tIns="0" rIns="0" bIns="0" rtlCol="0" anchor="ctr"/>
+          <a:lstStyle/>
+          <a:p>
+            <a:pPr algn="ctr" indent="0" marL="0">
+              <a:buNone/>
+            </a:pPr>
+            <a:r>
+              <a:rPr lang="en-US" sz="2400" b="1" dirty="0">
+                <a:solidFill>
+                  <a:srgbClr val="FFFFFF"/>
+                </a:solidFill>
+                <a:latin typeface="Calibri" pitchFamily="34" charset="0"/>
+                <a:ea typeface="Calibri" pitchFamily="34" charset="-122"/>
+                <a:cs typeface="Calibri" pitchFamily="34" charset="-120"/>
+              </a:rPr>
+              <a:t>Adaptability &amp; Leadership</a:t>
+            </a:r>
+            <a:endParaRPr lang="en-US" sz="2400" dirty="0"/>
+          </a:p>
+        </p:txBody>
+      </p:sp>
       <p:pic>
         <p:nvPicPr>
-          <p:cNvPr id="5" name="Skill 2 coin" descr="Essential Skill 2: Critical &amp; Creative Thinking">    </p:cNvPr>
+          <p:cNvPr id="6" name="Skill 6 coin" descr="Essential Skill 6: Professionalism">    </p:cNvPr>
           <p:cNvPicPr>
             <a:picLocks noChangeAspect="1"/>
           </p:cNvPicPr>
@@ -2138,17 +2270,56 @@
         </p:blipFill>
         <p:spPr>
           <a:xfrm>
-            <a:off x="3146908" y="1371600"/>
-            <a:ext cx="960120" cy="960120"/>
+            <a:off x="5501488" y="868680"/>
+            <a:ext cx="1188720" cy="1188720"/>
           </a:xfrm>
           <a:prstGeom prst="rect">
             <a:avLst/>
           </a:prstGeom>
         </p:spPr>
       </p:pic>
+      <p:sp>
+        <p:nvSpPr>
+          <p:cNvPr id="7" name="Text 3"/>
+          <p:cNvSpPr txBox="1"/>
+          <p:nvPr/>
+        </p:nvSpPr>
+        <p:spPr>
+          <a:xfrm>
+            <a:off x="4404208" y="2103120"/>
+            <a:ext cx="3383280" cy="457200"/>
+          </a:xfrm>
+          <a:prstGeom prst="rect">
+            <a:avLst/>
+          </a:prstGeom>
+          <a:noFill/>
+          <a:ln/>
+        </p:spPr>
+        <p:txBody>
+          <a:bodyPr wrap="square" lIns="0" tIns="0" rIns="0" bIns="0" rtlCol="0" anchor="ctr"/>
+          <a:lstStyle/>
+          <a:p>
+            <a:pPr algn="ctr" indent="0" marL="0">
+              <a:buNone/>
+            </a:pPr>
+            <a:r>
+              <a:rPr lang="en-US" sz="2400" b="1" dirty="0">
+                <a:solidFill>
+                  <a:srgbClr val="FFFFFF"/>
+                </a:solidFill>
+                <a:latin typeface="Calibri" pitchFamily="34" charset="0"/>
+                <a:ea typeface="Calibri" pitchFamily="34" charset="-122"/>
+                <a:cs typeface="Calibri" pitchFamily="34" charset="-120"/>
+              </a:rPr>
+              <a:t>Professionalism</a:t>
+            </a:r>
+            <a:endParaRPr lang="en-US" sz="2400" dirty="0"/>
+          </a:p>
+        </p:txBody>
+      </p:sp>
       <p:pic>
         <p:nvPicPr>
-          <p:cNvPr id="6" name="Skill 3 coin" descr="Essential Skill 3: Quantitative Reasoning">    </p:cNvPr>
+          <p:cNvPr id="8" name="Skill 9 coin" descr="Essential Skill 9: Knowledge Application">    </p:cNvPr>
           <p:cNvPicPr>
             <a:picLocks noChangeAspect="1"/>
           </p:cNvPicPr>
@@ -2162,120 +2333,24 @@
         </p:blipFill>
         <p:spPr>
           <a:xfrm>
-            <a:off x="4381348" y="1371600"/>
-            <a:ext cx="960120" cy="960120"/>
+            <a:off x="8884768" y="868680"/>
+            <a:ext cx="1188720" cy="1188720"/>
           </a:xfrm>
           <a:prstGeom prst="rect">
             <a:avLst/>
           </a:prstGeom>
         </p:spPr>
       </p:pic>
-      <p:pic>
-        <p:nvPicPr>
-          <p:cNvPr id="7" name="Skill 4 coin" descr="Essential Skill 4: Interpersonal Relations">    </p:cNvPr>
-          <p:cNvPicPr>
-            <a:picLocks noChangeAspect="1"/>
-          </p:cNvPicPr>
-          <p:nvPr/>
-        </p:nvPicPr>
-        <p:blipFill>
-          <a:blip r:embed="rId4"/>
-          <a:stretch>
-            <a:fillRect/>
-          </a:stretch>
-        </p:blipFill>
-        <p:spPr>
-          <a:xfrm>
-            <a:off x="5615788" y="1371600"/>
-            <a:ext cx="960120" cy="960120"/>
-          </a:xfrm>
-          <a:prstGeom prst="rect">
-            <a:avLst/>
-          </a:prstGeom>
-        </p:spPr>
-      </p:pic>
-      <p:pic>
-        <p:nvPicPr>
-          <p:cNvPr id="8" name="Skill 7 coin" descr="Essential Skill 7: Civic Engagement">    </p:cNvPr>
-          <p:cNvPicPr>
-            <a:picLocks noChangeAspect="1"/>
-          </p:cNvPicPr>
-          <p:nvPr/>
-        </p:nvPicPr>
-        <p:blipFill>
-          <a:blip r:embed="rId5"/>
-          <a:stretch>
-            <a:fillRect/>
-          </a:stretch>
-        </p:blipFill>
-        <p:spPr>
-          <a:xfrm>
-            <a:off x="6850228" y="1371600"/>
-            <a:ext cx="960120" cy="960120"/>
-          </a:xfrm>
-          <a:prstGeom prst="rect">
-            <a:avLst/>
-          </a:prstGeom>
-        </p:spPr>
-      </p:pic>
-      <p:pic>
-        <p:nvPicPr>
-          <p:cNvPr id="9" name="Skill 8 coin" descr="Essential Skill 8: Collaboration &amp; Teamwork">    </p:cNvPr>
-          <p:cNvPicPr>
-            <a:picLocks noChangeAspect="1"/>
-          </p:cNvPicPr>
-          <p:nvPr/>
-        </p:nvPicPr>
-        <p:blipFill>
-          <a:blip r:embed="rId6"/>
-          <a:stretch>
-            <a:fillRect/>
-          </a:stretch>
-        </p:blipFill>
-        <p:spPr>
-          <a:xfrm>
-            <a:off x="8084668" y="1371600"/>
-            <a:ext cx="960120" cy="960120"/>
-          </a:xfrm>
-          <a:prstGeom prst="rect">
-            <a:avLst/>
-          </a:prstGeom>
-        </p:spPr>
-      </p:pic>
-      <p:pic>
-        <p:nvPicPr>
-          <p:cNvPr id="10" name="Skill 10 coin" descr="Essential Skill 10: Information Literacy">    </p:cNvPr>
-          <p:cNvPicPr>
-            <a:picLocks noChangeAspect="1"/>
-          </p:cNvPicPr>
-          <p:nvPr/>
-        </p:nvPicPr>
-        <p:blipFill>
-          <a:blip r:embed="rId7"/>
-          <a:stretch>
-            <a:fillRect/>
-          </a:stretch>
-        </p:blipFill>
-        <p:spPr>
-          <a:xfrm>
-            <a:off x="9319108" y="1371600"/>
-            <a:ext cx="960120" cy="960120"/>
-          </a:xfrm>
-          <a:prstGeom prst="rect">
-            <a:avLst/>
-          </a:prstGeom>
-        </p:spPr>
-      </p:pic>
-      <p:sp>
-        <p:nvSpPr>
-          <p:cNvPr id="11" name="Text 2"/>
+      <p:sp>
+        <p:nvSpPr>
+          <p:cNvPr id="9" name="Text 4"/>
           <p:cNvSpPr txBox="1"/>
           <p:nvPr/>
         </p:nvSpPr>
         <p:spPr>
           <a:xfrm>
-            <a:off x="1371600" y="3703320"/>
-            <a:ext cx="9448495" cy="548640"/>
+            <a:off x="7787488" y="2103120"/>
+            <a:ext cx="3383280" cy="457200"/>
           </a:xfrm>
           <a:prstGeom prst="rect">
             <a:avLst/>
@@ -2284,22 +2359,61 @@
           <a:ln/>
         </p:spPr>
         <p:txBody>
-          <a:bodyPr wrap="square" lIns="0" tIns="0" rIns="0" bIns="0" rtlCol="0" anchor="t"/>
+          <a:bodyPr wrap="square" lIns="0" tIns="0" rIns="0" bIns="0" rtlCol="0" anchor="ctr"/>
           <a:lstStyle/>
           <a:p>
             <a:pPr algn="ctr" indent="0" marL="0">
               <a:buNone/>
             </a:pPr>
             <a:r>
-              <a:rPr lang="en-US" sz="2800" dirty="0">
-                <a:solidFill>
-                  <a:srgbClr val="D6EEFA"/>
+              <a:rPr lang="en-US" sz="2400" b="1" dirty="0">
+                <a:solidFill>
+                  <a:srgbClr val="FFFFFF"/>
                 </a:solidFill>
                 <a:latin typeface="Calibri" pitchFamily="34" charset="0"/>
                 <a:ea typeface="Calibri" pitchFamily="34" charset="-122"/>
                 <a:cs typeface="Calibri" pitchFamily="34" charset="-120"/>
               </a:rPr>
-              <a:t>Pick the one skill your story shows best.</a:t>
+              <a:t>Knowledge Application</a:t>
+            </a:r>
+            <a:endParaRPr lang="en-US" sz="2400" dirty="0"/>
+          </a:p>
+        </p:txBody>
+      </p:sp>
+      <p:sp>
+        <p:nvSpPr>
+          <p:cNvPr id="10" name="Text 5"/>
+          <p:cNvSpPr txBox="1"/>
+          <p:nvPr/>
+        </p:nvSpPr>
+        <p:spPr>
+          <a:xfrm>
+            <a:off x="1371600" y="3703320"/>
+            <a:ext cx="9448495" cy="502920"/>
+          </a:xfrm>
+          <a:prstGeom prst="rect">
+            <a:avLst/>
+          </a:prstGeom>
+          <a:noFill/>
+          <a:ln/>
+        </p:spPr>
+        <p:txBody>
+          <a:bodyPr wrap="square" lIns="0" tIns="0" rIns="0" bIns="0" rtlCol="0" anchor="t"/>
+          <a:lstStyle/>
+          <a:p>
+            <a:pPr algn="ctr" indent="0" marL="0">
+              <a:buNone/>
+            </a:pPr>
+            <a:r>
+              <a:rPr lang="en-US" sz="2800" dirty="0">
+                <a:solidFill>
+                  <a:srgbClr val="D6EEFA"/>
+                </a:solidFill>
+                <a:latin typeface="Calibri" pitchFamily="34" charset="0"/>
+                <a:ea typeface="Calibri" pitchFamily="34" charset="-122"/>
+                <a:cs typeface="Calibri" pitchFamily="34" charset="-120"/>
+              </a:rPr>
+              <a:t>Each one gets its own story.</a:t>
             </a:r>
             <a:endParaRPr lang="en-US" sz="2800" dirty="0"/>
           </a:p>
@@ -2307,7 +2421,7 @@
       </p:sp>
       <p:sp>
         <p:nvSpPr>
-          <p:cNvPr id="12" name="Decorative: prompt card">
+          <p:cNvPr id="11" name="Decorative: prompt card">
             <a:extLst>
               <a:ext uri="{C183D7F6-B498-43B3-948B-1728B52AA6E4}">
                 <adec:decorative xmlns:adec="http://schemas.microsoft.com/office/drawing/2017/decorative" val="1"/>
@@ -2340,7 +2454,7 @@
       </p:sp>
       <p:sp>
         <p:nvSpPr>
-          <p:cNvPr id="13" name="Text 4"/>
+          <p:cNvPr id="12" name="Text 7"/>
           <p:cNvSpPr txBox="1"/>
           <p:nvPr/>
         </p:nvSpPr>
@@ -2374,7 +2488,7 @@
                 <a:ea typeface="Calibri" pitchFamily="34" charset="-122"/>
                 <a:cs typeface="Calibri" pitchFamily="34" charset="-120"/>
               </a:rPr>
-              <a:t>I CHOSE THIS SKILL BECAUSE…</a:t>
+              <a:t>THIS STORY SHOWS…</a:t>
             </a:r>
             <a:endParaRPr lang="en-US" sz="2200" dirty="0"/>
           </a:p>
@@ -2394,7 +2508,7 @@
                 <a:ea typeface="Calibri" pitchFamily="34" charset="-122"/>
                 <a:cs typeface="Calibri" pitchFamily="34" charset="-120"/>
               </a:rPr>
-              <a:t>one sentence, in your own words</a:t>
+              <a:t>name the skill, then one real moment that proves it</a:t>
             </a:r>
             <a:endParaRPr lang="en-US" sz="2200" dirty="0"/>
           </a:p>
@@ -2411,6 +2525,417 @@
 <file path=ppt/slides/slide3.xml><?xml version="1.0" encoding="utf-8"?>
 <p:sld xmlns:a="http://schemas.openxmlformats.org/drawingml/2006/main" xmlns:r="http://schemas.openxmlformats.org/officeDocument/2006/relationships" xmlns:p="http://schemas.openxmlformats.org/presentationml/2006/main">
   <p:cSld name="Slide 3">
+    <p:bg>
+      <p:bgPr>
+        <a:solidFill>
+          <a:srgbClr val="00467F"/>
+        </a:solidFill>
+      </p:bgPr>
+    </p:bg>
+    <p:spTree>
+      <p:nvGrpSpPr>
+        <p:cNvPr id="1" name=""/>
+        <p:cNvGrpSpPr/>
+        <p:nvPr/>
+      </p:nvGrpSpPr>
+      <p:grpSpPr>
+        <a:xfrm>
+          <a:off x="0" y="0"/>
+          <a:ext cx="0" cy="0"/>
+          <a:chOff x="0" y="0"/>
+          <a:chExt cx="0" cy="0"/>
+        </a:xfrm>
+      </p:grpSpPr>
+      <p:sp>
+        <p:nvSpPr>
+          <p:cNvPr id="2" name="Text 0"/>
+          <p:cNvSpPr/>
+          <p:nvPr>
+            <p:ph idx="100" type="title" hasCustomPrompt="1"/>
+          </p:nvPr>
+        </p:nvSpPr>
+        <p:spPr>
+          <a:xfrm>
+            <a:off x="1371600" y="2788920"/>
+            <a:ext cx="9448495" cy="868680"/>
+          </a:xfrm>
+          <a:prstGeom prst="rect">
+            <a:avLst/>
+          </a:prstGeom>
+          <a:noFill/>
+          <a:ln/>
+        </p:spPr>
+        <p:txBody>
+          <a:bodyPr wrap="square" lIns="0" tIns="0" rIns="0" bIns="0" rtlCol="0" anchor="ctr"/>
+          <a:lstStyle/>
+          <a:p>
+            <a:pPr algn="ctr" indent="0" marL="0">
+              <a:buNone/>
+            </a:pPr>
+            <a:r>
+              <a:rPr lang="en-US" sz="5400" b="1" spc="400" kern="0" dirty="0">
+                <a:solidFill>
+                  <a:srgbClr val="FFFFFF"/>
+                </a:solidFill>
+              </a:rPr>
+              <a:t>Choose your skill</a:t>
+            </a:r>
+            <a:endParaRPr lang="en-US" sz="5400" dirty="0"/>
+          </a:p>
+        </p:txBody>
+      </p:sp>
+      <p:sp>
+        <p:nvSpPr>
+          <p:cNvPr id="3" name="Text 1"/>
+          <p:cNvSpPr txBox="1"/>
+          <p:nvPr/>
+        </p:nvSpPr>
+        <p:spPr>
+          <a:xfrm>
+            <a:off x="1371600" y="685800"/>
+            <a:ext cx="9448495" cy="457200"/>
+          </a:xfrm>
+          <a:prstGeom prst="rect">
+            <a:avLst/>
+          </a:prstGeom>
+          <a:noFill/>
+          <a:ln/>
+        </p:spPr>
+        <p:txBody>
+          <a:bodyPr wrap="square" lIns="0" tIns="0" rIns="0" bIns="0" rtlCol="0" anchor="t"/>
+          <a:lstStyle/>
+          <a:p>
+            <a:pPr algn="ctr" indent="0" marL="0">
+              <a:buNone/>
+            </a:pPr>
+            <a:r>
+              <a:rPr lang="en-US" sz="2200" b="1" spc="400" kern="0" dirty="0">
+                <a:solidFill>
+                  <a:srgbClr val="E7A614"/>
+                </a:solidFill>
+                <a:latin typeface="Calibri" pitchFamily="34" charset="0"/>
+                <a:ea typeface="Calibri" pitchFamily="34" charset="-122"/>
+                <a:cs typeface="Calibri" pitchFamily="34" charset="-120"/>
+              </a:rPr>
+              <a:t>SETUP · YOUR CHOICE</a:t>
+            </a:r>
+            <a:endParaRPr lang="en-US" sz="2200" dirty="0"/>
+          </a:p>
+        </p:txBody>
+      </p:sp>
+      <p:pic>
+        <p:nvPicPr>
+          <p:cNvPr id="4" name="Skill 1 coin" descr="Essential Skill 1: Communication">    </p:cNvPr>
+          <p:cNvPicPr>
+            <a:picLocks noChangeAspect="1"/>
+          </p:cNvPicPr>
+          <p:nvPr/>
+        </p:nvPicPr>
+        <p:blipFill>
+          <a:blip r:embed="rId1"/>
+          <a:stretch>
+            <a:fillRect/>
+          </a:stretch>
+        </p:blipFill>
+        <p:spPr>
+          <a:xfrm>
+            <a:off x="1912468" y="1371600"/>
+            <a:ext cx="960120" cy="960120"/>
+          </a:xfrm>
+          <a:prstGeom prst="rect">
+            <a:avLst/>
+          </a:prstGeom>
+        </p:spPr>
+      </p:pic>
+      <p:pic>
+        <p:nvPicPr>
+          <p:cNvPr id="5" name="Skill 2 coin" descr="Essential Skill 2: Critical &amp; Creative Thinking">    </p:cNvPr>
+          <p:cNvPicPr>
+            <a:picLocks noChangeAspect="1"/>
+          </p:cNvPicPr>
+          <p:nvPr/>
+        </p:nvPicPr>
+        <p:blipFill>
+          <a:blip r:embed="rId2"/>
+          <a:stretch>
+            <a:fillRect/>
+          </a:stretch>
+        </p:blipFill>
+        <p:spPr>
+          <a:xfrm>
+            <a:off x="3146908" y="1371600"/>
+            <a:ext cx="960120" cy="960120"/>
+          </a:xfrm>
+          <a:prstGeom prst="rect">
+            <a:avLst/>
+          </a:prstGeom>
+        </p:spPr>
+      </p:pic>
+      <p:pic>
+        <p:nvPicPr>
+          <p:cNvPr id="6" name="Skill 3 coin" descr="Essential Skill 3: Quantitative Reasoning">    </p:cNvPr>
+          <p:cNvPicPr>
+            <a:picLocks noChangeAspect="1"/>
+          </p:cNvPicPr>
+          <p:nvPr/>
+        </p:nvPicPr>
+        <p:blipFill>
+          <a:blip r:embed="rId3"/>
+          <a:stretch>
+            <a:fillRect/>
+          </a:stretch>
+        </p:blipFill>
+        <p:spPr>
+          <a:xfrm>
+            <a:off x="4381348" y="1371600"/>
+            <a:ext cx="960120" cy="960120"/>
+          </a:xfrm>
+          <a:prstGeom prst="rect">
+            <a:avLst/>
+          </a:prstGeom>
+        </p:spPr>
+      </p:pic>
+      <p:pic>
+        <p:nvPicPr>
+          <p:cNvPr id="7" name="Skill 4 coin" descr="Essential Skill 4: Interpersonal Relations">    </p:cNvPr>
+          <p:cNvPicPr>
+            <a:picLocks noChangeAspect="1"/>
+          </p:cNvPicPr>
+          <p:nvPr/>
+        </p:nvPicPr>
+        <p:blipFill>
+          <a:blip r:embed="rId4"/>
+          <a:stretch>
+            <a:fillRect/>
+          </a:stretch>
+        </p:blipFill>
+        <p:spPr>
+          <a:xfrm>
+            <a:off x="5615788" y="1371600"/>
+            <a:ext cx="960120" cy="960120"/>
+          </a:xfrm>
+          <a:prstGeom prst="rect">
+            <a:avLst/>
+          </a:prstGeom>
+        </p:spPr>
+      </p:pic>
+      <p:pic>
+        <p:nvPicPr>
+          <p:cNvPr id="8" name="Skill 7 coin" descr="Essential Skill 7: Civic Engagement">    </p:cNvPr>
+          <p:cNvPicPr>
+            <a:picLocks noChangeAspect="1"/>
+          </p:cNvPicPr>
+          <p:nvPr/>
+        </p:nvPicPr>
+        <p:blipFill>
+          <a:blip r:embed="rId5"/>
+          <a:stretch>
+            <a:fillRect/>
+          </a:stretch>
+        </p:blipFill>
+        <p:spPr>
+          <a:xfrm>
+            <a:off x="6850228" y="1371600"/>
+            <a:ext cx="960120" cy="960120"/>
+          </a:xfrm>
+          <a:prstGeom prst="rect">
+            <a:avLst/>
+          </a:prstGeom>
+        </p:spPr>
+      </p:pic>
+      <p:pic>
+        <p:nvPicPr>
+          <p:cNvPr id="9" name="Skill 8 coin" descr="Essential Skill 8: Collaboration &amp; Teamwork">    </p:cNvPr>
+          <p:cNvPicPr>
+            <a:picLocks noChangeAspect="1"/>
+          </p:cNvPicPr>
+          <p:nvPr/>
+        </p:nvPicPr>
+        <p:blipFill>
+          <a:blip r:embed="rId6"/>
+          <a:stretch>
+            <a:fillRect/>
+          </a:stretch>
+        </p:blipFill>
+        <p:spPr>
+          <a:xfrm>
+            <a:off x="8084668" y="1371600"/>
+            <a:ext cx="960120" cy="960120"/>
+          </a:xfrm>
+          <a:prstGeom prst="rect">
+            <a:avLst/>
+          </a:prstGeom>
+        </p:spPr>
+      </p:pic>
+      <p:pic>
+        <p:nvPicPr>
+          <p:cNvPr id="10" name="Skill 10 coin" descr="Essential Skill 10: Information Literacy">    </p:cNvPr>
+          <p:cNvPicPr>
+            <a:picLocks noChangeAspect="1"/>
+          </p:cNvPicPr>
+          <p:nvPr/>
+        </p:nvPicPr>
+        <p:blipFill>
+          <a:blip r:embed="rId7"/>
+          <a:stretch>
+            <a:fillRect/>
+          </a:stretch>
+        </p:blipFill>
+        <p:spPr>
+          <a:xfrm>
+            <a:off x="9319108" y="1371600"/>
+            <a:ext cx="960120" cy="960120"/>
+          </a:xfrm>
+          <a:prstGeom prst="rect">
+            <a:avLst/>
+          </a:prstGeom>
+        </p:spPr>
+      </p:pic>
+      <p:sp>
+        <p:nvSpPr>
+          <p:cNvPr id="11" name="Text 2"/>
+          <p:cNvSpPr txBox="1"/>
+          <p:nvPr/>
+        </p:nvSpPr>
+        <p:spPr>
+          <a:xfrm>
+            <a:off x="1371600" y="3703320"/>
+            <a:ext cx="9448495" cy="548640"/>
+          </a:xfrm>
+          <a:prstGeom prst="rect">
+            <a:avLst/>
+          </a:prstGeom>
+          <a:noFill/>
+          <a:ln/>
+        </p:spPr>
+        <p:txBody>
+          <a:bodyPr wrap="square" lIns="0" tIns="0" rIns="0" bIns="0" rtlCol="0" anchor="t"/>
+          <a:lstStyle/>
+          <a:p>
+            <a:pPr algn="ctr" indent="0" marL="0">
+              <a:buNone/>
+            </a:pPr>
+            <a:r>
+              <a:rPr lang="en-US" sz="2800" dirty="0">
+                <a:solidFill>
+                  <a:srgbClr val="D6EEFA"/>
+                </a:solidFill>
+                <a:latin typeface="Calibri" pitchFamily="34" charset="0"/>
+                <a:ea typeface="Calibri" pitchFamily="34" charset="-122"/>
+                <a:cs typeface="Calibri" pitchFamily="34" charset="-120"/>
+              </a:rPr>
+              <a:t>Pick the one skill your story shows best.</a:t>
+            </a:r>
+            <a:endParaRPr lang="en-US" sz="2800" dirty="0"/>
+          </a:p>
+        </p:txBody>
+      </p:sp>
+      <p:sp>
+        <p:nvSpPr>
+          <p:cNvPr id="12" name="Decorative: prompt card">
+            <a:extLst>
+              <a:ext uri="{C183D7F6-B498-43B3-948B-1728B52AA6E4}">
+                <adec:decorative xmlns:adec="http://schemas.microsoft.com/office/drawing/2017/decorative" val="1"/>
+              </a:ext>
+            </a:extLst>
+          </p:cNvPr>
+          <p:cNvSpPr/>
+          <p:nvPr/>
+        </p:nvSpPr>
+        <p:spPr>
+          <a:xfrm>
+            <a:off x="2194560" y="4572000"/>
+            <a:ext cx="7802575" cy="1325880"/>
+          </a:xfrm>
+          <a:prstGeom prst="roundRect">
+            <a:avLst>
+              <a:gd name="adj" fmla="val 10345"/>
+            </a:avLst>
+          </a:prstGeom>
+          <a:solidFill>
+            <a:srgbClr val="FFFFFF"/>
+          </a:solidFill>
+          <a:ln w="31750">
+            <a:solidFill>
+              <a:srgbClr val="E7A614"/>
+            </a:solidFill>
+            <a:prstDash val="solid"/>
+          </a:ln>
+        </p:spPr>
+      </p:sp>
+      <p:sp>
+        <p:nvSpPr>
+          <p:cNvPr id="13" name="Text 4"/>
+          <p:cNvSpPr txBox="1"/>
+          <p:nvPr/>
+        </p:nvSpPr>
+        <p:spPr>
+          <a:xfrm>
+            <a:off x="2560320" y="4754880"/>
+            <a:ext cx="7071055" cy="1005840"/>
+          </a:xfrm>
+          <a:prstGeom prst="rect">
+            <a:avLst/>
+          </a:prstGeom>
+          <a:noFill/>
+          <a:ln/>
+        </p:spPr>
+        <p:txBody>
+          <a:bodyPr wrap="square" lIns="0" tIns="0" rIns="0" bIns="0" rtlCol="0" anchor="ctr"/>
+          <a:lstStyle/>
+          <a:p>
+            <a:pPr algn="ctr" indent="0" marL="0">
+              <a:spcBef>
+                <a:spcPts val="400"/>
+              </a:spcBef>
+              <a:buNone/>
+            </a:pPr>
+            <a:r>
+              <a:rPr lang="en-US" sz="2200" b="1" spc="200" kern="0" dirty="0">
+                <a:solidFill>
+                  <a:srgbClr val="0B5F86"/>
+                </a:solidFill>
+                <a:latin typeface="Calibri" pitchFamily="34" charset="0"/>
+                <a:ea typeface="Calibri" pitchFamily="34" charset="-122"/>
+                <a:cs typeface="Calibri" pitchFamily="34" charset="-120"/>
+              </a:rPr>
+              <a:t>I CHOSE THIS SKILL BECAUSE…</a:t>
+            </a:r>
+            <a:endParaRPr lang="en-US" sz="2200" dirty="0"/>
+          </a:p>
+          <a:p>
+            <a:pPr algn="ctr" indent="0" marL="0">
+              <a:spcBef>
+                <a:spcPts val="400"/>
+              </a:spcBef>
+              <a:buNone/>
+            </a:pPr>
+            <a:r>
+              <a:rPr lang="en-US" sz="2400" i="1" dirty="0">
+                <a:solidFill>
+                  <a:srgbClr val="52606D"/>
+                </a:solidFill>
+                <a:latin typeface="Calibri" pitchFamily="34" charset="0"/>
+                <a:ea typeface="Calibri" pitchFamily="34" charset="-122"/>
+                <a:cs typeface="Calibri" pitchFamily="34" charset="-120"/>
+              </a:rPr>
+              <a:t>one sentence, in your own words</a:t>
+            </a:r>
+            <a:endParaRPr lang="en-US" sz="2200" dirty="0"/>
+          </a:p>
+        </p:txBody>
+      </p:sp>
+    </p:spTree>
+  </p:cSld>
+  <p:clrMapOvr>
+    <a:masterClrMapping/>
+  </p:clrMapOvr>
+</p:sld>
+</file>
+
+<file path=ppt/slides/slide4.xml><?xml version="1.0" encoding="utf-8"?>
+<p:sld xmlns:a="http://schemas.openxmlformats.org/drawingml/2006/main" xmlns:r="http://schemas.openxmlformats.org/officeDocument/2006/relationships" xmlns:p="http://schemas.openxmlformats.org/presentationml/2006/main">
+  <p:cSld name="Slide 4">
     <p:bg>
       <p:bgPr>
         <a:solidFill>
@@ -2752,9 +3277,9 @@
 </p:sld>
 </file>
 
-<file path=ppt/slides/slide4.xml><?xml version="1.0" encoding="utf-8"?>
+<file path=ppt/slides/slide5.xml><?xml version="1.0" encoding="utf-8"?>
 <p:sld xmlns:a="http://schemas.openxmlformats.org/drawingml/2006/main" xmlns:r="http://schemas.openxmlformats.org/officeDocument/2006/relationships" xmlns:p="http://schemas.openxmlformats.org/presentationml/2006/main">
-  <p:cSld name="Slide 4">
+  <p:cSld name="Slide 5">
     <p:bg>
       <p:bgPr>
         <a:solidFill>
@@ -3096,9 +3621,9 @@
 </p:sld>
 </file>
 
-<file path=ppt/slides/slide5.xml><?xml version="1.0" encoding="utf-8"?>
+<file path=ppt/slides/slide6.xml><?xml version="1.0" encoding="utf-8"?>
 <p:sld xmlns:a="http://schemas.openxmlformats.org/drawingml/2006/main" xmlns:r="http://schemas.openxmlformats.org/officeDocument/2006/relationships" xmlns:p="http://schemas.openxmlformats.org/presentationml/2006/main">
-  <p:cSld name="Slide 5">
+  <p:cSld name="Slide 6">
     <p:bg>
       <p:bgPr>
         <a:solidFill>
@@ -3440,9 +3965,9 @@
 </p:sld>
 </file>
 
-<file path=ppt/slides/slide6.xml><?xml version="1.0" encoding="utf-8"?>
+<file path=ppt/slides/slide7.xml><?xml version="1.0" encoding="utf-8"?>
 <p:sld xmlns:a="http://schemas.openxmlformats.org/drawingml/2006/main" xmlns:r="http://schemas.openxmlformats.org/officeDocument/2006/relationships" xmlns:p="http://schemas.openxmlformats.org/presentationml/2006/main">
-  <p:cSld name="Slide 6">
+  <p:cSld name="Slide 7">
     <p:bg>
       <p:bgPr>
         <a:solidFill>
@@ -3784,9 +4309,9 @@
 </p:sld>
 </file>
 
-<file path=ppt/slides/slide7.xml><?xml version="1.0" encoding="utf-8"?>
+<file path=ppt/slides/slide8.xml><?xml version="1.0" encoding="utf-8"?>
 <p:sld xmlns:a="http://schemas.openxmlformats.org/drawingml/2006/main" xmlns:r="http://schemas.openxmlformats.org/officeDocument/2006/relationships" xmlns:p="http://schemas.openxmlformats.org/presentationml/2006/main">
-  <p:cSld name="Slide 7">
+  <p:cSld name="Slide 8">
     <p:bg>
       <p:bgPr>
         <a:solidFill>

</xml_diff>